<commit_message>
build: rebuild evidence deck from jury_report and git describe
python scripts/build_deck.py reads jury_report.md, versions.py, PILOT budget, and git describe. Footer is no longer a hardcoded 0.1.8. pptx metadata is Коньков Д.В. / SynAPS with unique slide titles. CI diffs docs/DECK_TEXT.txt.
</commit_message>
<xml_diff>
--- a/SynAPS_v8_Evidence.pptx
+++ b/SynAPS_v8_Evidence.pptx
@@ -1832,7 +1832,7 @@
 
 <file path=ppt/slides/slide1.xml><?xml version="1.0" encoding="utf-8"?>
 <p:sld xmlns:a="http://schemas.openxmlformats.org/drawingml/2006/main" xmlns:r="http://schemas.openxmlformats.org/officeDocument/2006/relationships" xmlns:p="http://schemas.openxmlformats.org/presentationml/2006/main">
-  <p:cSld name="Slide 1">
+  <p:cSld name="01 Title">
     <p:bg>
       <p:bgPr>
         <a:solidFill>
@@ -1907,7 +1907,7 @@
                 <a:ea typeface="Calibri" pitchFamily="34" charset="-122"/>
                 <a:cs typeface="Calibri" pitchFamily="34" charset="-120"/>
               </a:rPr>
-              <a:t>ЭНЕРГОТЕХНОХАБ ПЕТЕРБУРГ  ·  НАПРАВЛЕНИЕ 02  ·  ПРИЁМ ДО 25.09.2026</a:t>
+              <a:t>ЭНЕРГОТЕХНОХАБ ПЕТЕРБУРГ  ·  НАПРАВЛЕНИЕ 02  ·  ПРИЁМ ДО 25.09.2026  ·  P6</a:t>
             </a:r>
             <a:endParaRPr lang="en-US" sz="1300" dirty="0"/>
           </a:p>
@@ -2100,7 +2100,7 @@
                 <a:ea typeface="Calibri" pitchFamily="34" charset="-122"/>
                 <a:cs typeface="Calibri" pitchFamily="34" charset="-120"/>
               </a:rPr>
-              <a:t>0.1.8</a:t>
+              <a:t>0.1.8 V1</a:t>
             </a:r>
             <a:endParaRPr lang="en-US" sz="1400" dirty="0"/>
           </a:p>
@@ -2198,7 +2198,7 @@
                 <a:ea typeface="Calibri" pitchFamily="34" charset="-122"/>
                 <a:cs typeface="Calibri" pitchFamily="34" charset="-120"/>
               </a:rPr>
-              <a:t>самооценка ISO 16290 TRL 4</a:t>
+              <a:t>TRL 4 по ISO 16290: лабораторные фикстуры, не пилот на предприятии  V3</a:t>
             </a:r>
             <a:endParaRPr lang="en-US" sz="1400" dirty="0"/>
           </a:p>
@@ -2528,7 +2528,7 @@
                 <a:ea typeface="Calibri" pitchFamily="34" charset="-122"/>
                 <a:cs typeface="Calibri" pitchFamily="34" charset="-120"/>
               </a:rPr>
-              <a:t>SynAPS-GridPlan 0.1.8  ·  лабораторный прототип  ·  не пилот</a:t>
+              <a:t>SynAPS-GridPlan v0.1.8-24-g5f542fd-dirty  ·  лабораторный прототип  ·  не пилот</a:t>
             </a:r>
             <a:endParaRPr lang="en-US" sz="1100" dirty="0"/>
           </a:p>
@@ -2583,7 +2583,7 @@
 
 <file path=ppt/slides/slide10.xml><?xml version="1.0" encoding="utf-8"?>
 <p:sld xmlns:a="http://schemas.openxmlformats.org/drawingml/2006/main" xmlns:r="http://schemas.openxmlformats.org/officeDocument/2006/relationships" xmlns:p="http://schemas.openxmlformats.org/presentationml/2006/main">
-  <p:cSld name="Slide 10">
+  <p:cSld name="10 Team">
     <p:bg>
       <p:bgPr>
         <a:solidFill>
@@ -3108,7 +3108,7 @@
                 <a:ea typeface="Calibri" pitchFamily="34" charset="-122"/>
                 <a:cs typeface="Calibri" pitchFamily="34" charset="-120"/>
               </a:rPr>
-              <a:t>SynAPS-GridPlan 0.1.8  ·  лабораторный прототип  ·  не пилот</a:t>
+              <a:t>SynAPS-GridPlan v0.1.8-24-g5f542fd-dirty  ·  лабораторный прототип  ·  не пилот</a:t>
             </a:r>
             <a:endParaRPr lang="en-US" sz="1100" dirty="0"/>
           </a:p>
@@ -3163,7 +3163,7 @@
 
 <file path=ppt/slides/slide11.xml><?xml version="1.0" encoding="utf-8"?>
 <p:sld xmlns:a="http://schemas.openxmlformats.org/drawingml/2006/main" xmlns:r="http://schemas.openxmlformats.org/officeDocument/2006/relationships" xmlns:p="http://schemas.openxmlformats.org/presentationml/2006/main">
-  <p:cSld name="Slide 11">
+  <p:cSld name="11 Ask">
     <p:bg>
       <p:bgPr>
         <a:solidFill>
@@ -3688,7 +3688,7 @@
                 <a:ea typeface="Calibri" pitchFamily="34" charset="-122"/>
                 <a:cs typeface="Calibri" pitchFamily="34" charset="-120"/>
               </a:rPr>
-              <a:t>SynAPS-GridPlan 0.1.8  ·  лабораторный прототип  ·  не пилот</a:t>
+              <a:t>SynAPS-GridPlan v0.1.8-24-g5f542fd-dirty  ·  лабораторный прототип  ·  не пилот</a:t>
             </a:r>
             <a:endParaRPr lang="en-US" sz="1100" dirty="0"/>
           </a:p>
@@ -3743,7 +3743,7 @@
 
 <file path=ppt/slides/slide12.xml><?xml version="1.0" encoding="utf-8"?>
 <p:sld xmlns:a="http://schemas.openxmlformats.org/drawingml/2006/main" xmlns:r="http://schemas.openxmlformats.org/officeDocument/2006/relationships" xmlns:p="http://schemas.openxmlformats.org/presentationml/2006/main">
-  <p:cSld name="Slide 12">
+  <p:cSld name="12 Repro">
     <p:bg>
       <p:bgPr>
         <a:solidFill>
@@ -3969,7 +3969,7 @@
                 <a:ea typeface="Calibri" pitchFamily="34" charset="-122"/>
                 <a:cs typeface="Calibri" pitchFamily="34" charset="-120"/>
               </a:rPr>
-              <a:t>Должно напечатать 0.1.8 и пин SynAPS 6178c93…  Jury + CP-SAT на том же res_severny. Реестр: docs/CLAIMS_REGISTRY.md. Почему не v7: docs/PITCH_V7_FACTCHECK.md. Программа: https://www.etechhubspb.ru/accelerator</a:t>
+              <a:t>Должно напечатать 0.1.8 и пин SynAPS 6178c93b705f… [V1] [V2]. Jury + CP-SAT на том же res_severny. Реестр: docs/CLAIMS_REGISTRY.md. Почему не v7: docs/PITCH_V7_FACTCHECK.md. Программа: https://www.etechhubspb.ru/accelerator</a:t>
             </a:r>
             <a:endParaRPr lang="en-US" sz="1600" dirty="0"/>
           </a:p>
@@ -4047,7 +4047,7 @@
                 <a:ea typeface="Calibri" pitchFamily="34" charset="-122"/>
                 <a:cs typeface="Calibri" pitchFamily="34" charset="-120"/>
               </a:rPr>
-              <a:t>SynAPS-GridPlan 0.1.8  ·  лабораторный прототип  ·  не пилот</a:t>
+              <a:t>SynAPS-GridPlan v0.1.8-24-g5f542fd-dirty  ·  лабораторный прототип  ·  не пилот</a:t>
             </a:r>
             <a:endParaRPr lang="en-US" sz="1100" dirty="0"/>
           </a:p>
@@ -4102,7 +4102,7 @@
 
 <file path=ppt/slides/slide2.xml><?xml version="1.0" encoding="utf-8"?>
 <p:sld xmlns:a="http://schemas.openxmlformats.org/drawingml/2006/main" xmlns:r="http://schemas.openxmlformats.org/officeDocument/2006/relationships" xmlns:p="http://schemas.openxmlformats.org/presentationml/2006/main">
-  <p:cSld name="Slide 2">
+  <p:cSld name="02 Thesis">
     <p:bg>
       <p:bgPr>
         <a:solidFill>
@@ -4588,7 +4588,7 @@
                 <a:ea typeface="Calibri" pitchFamily="34" charset="-122"/>
                 <a:cs typeface="Calibri" pitchFamily="34" charset="-120"/>
               </a:rPr>
-              <a:t>SynAPS-GridPlan 0.1.8  ·  лабораторный прототип  ·  не пилот</a:t>
+              <a:t>SynAPS-GridPlan v0.1.8-24-g5f542fd-dirty  ·  лабораторный прототип  ·  не пилот</a:t>
             </a:r>
             <a:endParaRPr lang="en-US" sz="1100" dirty="0"/>
           </a:p>
@@ -4643,7 +4643,7 @@
 
 <file path=ppt/slides/slide3.xml><?xml version="1.0" encoding="utf-8"?>
 <p:sld xmlns:a="http://schemas.openxmlformats.org/drawingml/2006/main" xmlns:r="http://schemas.openxmlformats.org/officeDocument/2006/relationships" xmlns:p="http://schemas.openxmlformats.org/presentationml/2006/main">
-  <p:cSld name="Slide 3">
+  <p:cSld name="03 Product">
     <p:bg>
       <p:bgPr>
         <a:solidFill>
@@ -5480,7 +5480,7 @@
                 <a:ea typeface="Calibri" pitchFamily="34" charset="-122"/>
                 <a:cs typeface="Calibri" pitchFamily="34" charset="-120"/>
               </a:rPr>
-              <a:t>SynAPS-GridPlan 0.1.8  ·  лабораторный прототип  ·  не пилот</a:t>
+              <a:t>SynAPS-GridPlan v0.1.8-24-g5f542fd-dirty  ·  лабораторный прототип  ·  не пилот</a:t>
             </a:r>
             <a:endParaRPr lang="en-US" sz="1100" dirty="0"/>
           </a:p>
@@ -5535,7 +5535,7 @@
 
 <file path=ppt/slides/slide4.xml><?xml version="1.0" encoding="utf-8"?>
 <p:sld xmlns:a="http://schemas.openxmlformats.org/drawingml/2006/main" xmlns:r="http://schemas.openxmlformats.org/officeDocument/2006/relationships" xmlns:p="http://schemas.openxmlformats.org/presentationml/2006/main">
-  <p:cSld name="Slide 4">
+  <p:cSld name="04 Evidence FIFO vs GREED vs CPSAT">
     <p:bg>
       <p:bgPr>
         <a:solidFill>
@@ -5590,7 +5590,7 @@
                 <a:ea typeface="Calibri" pitchFamily="34" charset="-122"/>
                 <a:cs typeface="Calibri" pitchFamily="34" charset="-120"/>
               </a:rPr>
-              <a:t>ЛАБОРАТОРИЯ  ·  ОДИН ИНСТАНС</a:t>
+              <a:t>ЛАБОРАТОРИЯ  ·  ОДИН ИНСТАНС  ·  B1 B2 B3 B4 B5 B7</a:t>
             </a:r>
             <a:endParaRPr lang="en-US" sz="1200" dirty="0"/>
           </a:p>
@@ -6894,7 +6894,7 @@
                 <a:ea typeface="Calibri" pitchFamily="34" charset="-122"/>
                 <a:cs typeface="Calibri" pitchFamily="34" charset="-120"/>
               </a:rPr>
-              <a:t>SynAPS-GridPlan 0.1.8  ·  лабораторный прототип  ·  не пилот</a:t>
+              <a:t>SynAPS-GridPlan v0.1.8-24-g5f542fd-dirty  ·  лабораторный прототип  ·  не пилот</a:t>
             </a:r>
             <a:endParaRPr lang="en-US" sz="1100" dirty="0"/>
           </a:p>
@@ -6949,7 +6949,7 @@
 
 <file path=ppt/slides/slide5.xml><?xml version="1.0" encoding="utf-8"?>
 <p:sld xmlns:a="http://schemas.openxmlformats.org/drawingml/2006/main" xmlns:r="http://schemas.openxmlformats.org/officeDocument/2006/relationships" xmlns:p="http://schemas.openxmlformats.org/presentationml/2006/main">
-  <p:cSld name="Slide 5">
+  <p:cSld name="05 Limits">
     <p:bg>
       <p:bgPr>
         <a:solidFill>
@@ -7670,7 +7670,7 @@
                 <a:ea typeface="Calibri" pitchFamily="34" charset="-122"/>
                 <a:cs typeface="Calibri" pitchFamily="34" charset="-120"/>
               </a:rPr>
-              <a:t>SynAPS-GridPlan 0.1.8  ·  лабораторный прототип  ·  не пилот</a:t>
+              <a:t>SynAPS-GridPlan v0.1.8-24-g5f542fd-dirty  ·  лабораторный прототип  ·  не пилот</a:t>
             </a:r>
             <a:endParaRPr lang="en-US" sz="1100" dirty="0"/>
           </a:p>
@@ -7725,7 +7725,7 @@
 
 <file path=ppt/slides/slide6.xml><?xml version="1.0" encoding="utf-8"?>
 <p:sld xmlns:a="http://schemas.openxmlformats.org/drawingml/2006/main" xmlns:r="http://schemas.openxmlformats.org/officeDocument/2006/relationships" xmlns:p="http://schemas.openxmlformats.org/presentationml/2006/main">
-  <p:cSld name="Slide 6">
+  <p:cSld name="06 Customer">
     <p:bg>
       <p:bgPr>
         <a:solidFill>
@@ -8230,7 +8230,7 @@
                 <a:ea typeface="Calibri" pitchFamily="34" charset="-122"/>
                 <a:cs typeface="Calibri" pitchFamily="34" charset="-120"/>
               </a:rPr>
-              <a:t>SynAPS-GridPlan 0.1.8  ·  лабораторный прототип  ·  не пилот</a:t>
+              <a:t>SynAPS-GridPlan v0.1.8-24-g5f542fd-dirty  ·  лабораторный прототип  ·  не пилот</a:t>
             </a:r>
             <a:endParaRPr lang="en-US" sz="1100" dirty="0"/>
           </a:p>
@@ -8285,7 +8285,7 @@
 
 <file path=ppt/slides/slide7.xml><?xml version="1.0" encoding="utf-8"?>
 <p:sld xmlns:a="http://schemas.openxmlformats.org/drawingml/2006/main" xmlns:r="http://schemas.openxmlformats.org/officeDocument/2006/relationships" xmlns:p="http://schemas.openxmlformats.org/presentationml/2006/main">
-  <p:cSld name="Slide 7">
+  <p:cSld name="07 UGT">
     <p:bg>
       <p:bgPr>
         <a:solidFill>
@@ -9315,7 +9315,7 @@
                 <a:ea typeface="Calibri" pitchFamily="34" charset="-122"/>
                 <a:cs typeface="Calibri" pitchFamily="34" charset="-120"/>
               </a:rPr>
-              <a:t>SynAPS-GridPlan 0.1.8  ·  лабораторный прототип  ·  не пилот</a:t>
+              <a:t>SynAPS-GridPlan v0.1.8-24-g5f542fd-dirty  ·  лабораторный прототип  ·  не пилот</a:t>
             </a:r>
             <a:endParaRPr lang="en-US" sz="1100" dirty="0"/>
           </a:p>
@@ -9370,7 +9370,7 @@
 
 <file path=ppt/slides/slide8.xml><?xml version="1.0" encoding="utf-8"?>
 <p:sld xmlns:a="http://schemas.openxmlformats.org/drawingml/2006/main" xmlns:r="http://schemas.openxmlformats.org/officeDocument/2006/relationships" xmlns:p="http://schemas.openxmlformats.org/presentationml/2006/main">
-  <p:cSld name="Slide 8">
+  <p:cSld name="08 Pilot">
     <p:bg>
       <p:bgPr>
         <a:solidFill>
@@ -9993,7 +9993,7 @@
                 <a:ea typeface="Calibri" pitchFamily="34" charset="-122"/>
                 <a:cs typeface="Calibri" pitchFamily="34" charset="-120"/>
               </a:rPr>
-              <a:t>SynAPS-GridPlan 0.1.8  ·  лабораторный прототип  ·  не пилот</a:t>
+              <a:t>SynAPS-GridPlan v0.1.8-24-g5f542fd-dirty  ·  лабораторный прототип  ·  не пилот</a:t>
             </a:r>
             <a:endParaRPr lang="en-US" sz="1100" dirty="0"/>
           </a:p>
@@ -10048,7 +10048,7 @@
 
 <file path=ppt/slides/slide9.xml><?xml version="1.0" encoding="utf-8"?>
 <p:sld xmlns:a="http://schemas.openxmlformats.org/drawingml/2006/main" xmlns:r="http://schemas.openxmlformats.org/officeDocument/2006/relationships" xmlns:p="http://schemas.openxmlformats.org/presentationml/2006/main">
-  <p:cSld name="Slide 9">
+  <p:cSld name="09 Budget assumption">
     <p:bg>
       <p:bgPr>
         <a:solidFill>
@@ -10103,7 +10103,7 @@
                 <a:ea typeface="Calibri" pitchFamily="34" charset="-122"/>
                 <a:cs typeface="Calibri" pitchFamily="34" charset="-120"/>
               </a:rPr>
-              <a:t>ПРИЗ ПРОГРАММЫ  ·  ПРЕДМЕТ СОГЛАСОВАНИЯ</a:t>
+              <a:t>ПРИЗ ПРОГРАММЫ  ·  ПРЕДМЕТ СОГЛАСОВАНИЯ  ·  P8 M6</a:t>
             </a:r>
             <a:endParaRPr lang="en-US" sz="1200" dirty="0"/>
           </a:p>
@@ -11314,7 +11314,7 @@
                 <a:ea typeface="Calibri" pitchFamily="34" charset="-122"/>
                 <a:cs typeface="Calibri" pitchFamily="34" charset="-120"/>
               </a:rPr>
-              <a:t>SynAPS-GridPlan 0.1.8  ·  лабораторный прототип  ·  не пилот</a:t>
+              <a:t>SynAPS-GridPlan v0.1.8-24-g5f542fd-dirty  ·  лабораторный прототип  ·  не пилот</a:t>
             </a:r>
             <a:endParaRPr lang="en-US" sz="1100" dirty="0"/>
           </a:p>

</xml_diff>